<commit_message>
docs: align report to center, condense to 17 pages, update cover layout and supervisor to MNNIT Prayagraj
</commit_message>
<xml_diff>
--- a/HomeWorth_AI_Presentation.pptx
+++ b/HomeWorth_AI_Presentation.pptx
@@ -3502,19 +3502,15 @@
               </a:defRPr>
             </a:pPr>
             <a:r>
-              <a:t>Department of Computer Science and Engineering</a:t>
+              <a:t>Associate Professor</a:t>
             </a:r>
             <a:br/>
             <a:r>
-              <a:t>(Artificial Intelligence &amp; Machine Learning)</a:t>
+              <a:t>Department of Computer Science &amp; Engineering</a:t>
             </a:r>
             <a:br/>
             <a:r>
-              <a:t>United College of Engineering &amp; Research (UCER), Prayagraj</a:t>
-            </a:r>
-            <a:br/>
-            <a:r>
-              <a:t>Affiliated to Dr. A.P.J. AKTU, Lucknow (2026-27)</a:t>
+              <a:t>Motilal Nehru National Institute of Technology (MNNIT), Prayagraj</a:t>
             </a:r>
           </a:p>
         </p:txBody>
@@ -5880,7 +5876,7 @@
               </a:defRPr>
             </a:pPr>
             <a:r>
-              <a:t>•  Dr. Divya Kumar (Project Supervisor): For invaluable mentorship, architectural feedback, and rigorous academic oversight.</a:t>
+              <a:t>•  Dr. Divya Kumar (Project Supervisor, MNNIT Prayagraj): For invaluable mentorship, architectural feedback, and rigorous academic oversight.</a:t>
             </a:r>
           </a:p>
           <a:p>

</xml_diff>